<commit_message>
Adjustements to presentation and report
</commit_message>
<xml_diff>
--- a/reports/presentation.pptx
+++ b/reports/presentation.pptx
@@ -4,17 +4,20 @@
   <p:sldMasterIdLst>
     <p:sldMasterId id="2147483648" r:id="rId1"/>
   </p:sldMasterIdLst>
+  <p:notesMasterIdLst>
+    <p:notesMasterId r:id="rId12"/>
+  </p:notesMasterIdLst>
   <p:sldIdLst>
-    <p:sldId id="256" r:id="rId7"/>
-    <p:sldId id="257" r:id="rId8"/>
-    <p:sldId id="258" r:id="rId9"/>
-    <p:sldId id="259" r:id="rId10"/>
-    <p:sldId id="260" r:id="rId11"/>
-    <p:sldId id="261" r:id="rId12"/>
-    <p:sldId id="262" r:id="rId13"/>
-    <p:sldId id="263" r:id="rId14"/>
-    <p:sldId id="264" r:id="rId15"/>
-    <p:sldId id="265" r:id="rId16"/>
+    <p:sldId id="256" r:id="rId2"/>
+    <p:sldId id="257" r:id="rId3"/>
+    <p:sldId id="258" r:id="rId4"/>
+    <p:sldId id="259" r:id="rId5"/>
+    <p:sldId id="260" r:id="rId6"/>
+    <p:sldId id="261" r:id="rId7"/>
+    <p:sldId id="262" r:id="rId8"/>
+    <p:sldId id="263" r:id="rId9"/>
+    <p:sldId id="264" r:id="rId10"/>
+    <p:sldId id="265" r:id="rId11"/>
   </p:sldIdLst>
   <p:sldSz cx="9144000" cy="6858000" type="screen4x3"/>
   <p:notesSz cx="6858000" cy="9144000"/>
@@ -113,7 +116,598 @@
       </a:defRPr>
     </a:lvl9pPr>
   </p:defaultTextStyle>
+  <p:extLst>
+    <p:ext uri="{EFAFB233-063F-42B5-8137-9DF3F51BA10A}">
+      <p15:sldGuideLst xmlns:p15="http://schemas.microsoft.com/office/powerpoint/2012/main">
+        <p15:guide id="1" orient="horz" pos="2160">
+          <p15:clr>
+            <a:srgbClr val="A4A3A4"/>
+          </p15:clr>
+        </p15:guide>
+        <p15:guide id="2" pos="2880">
+          <p15:clr>
+            <a:srgbClr val="A4A3A4"/>
+          </p15:clr>
+        </p15:guide>
+      </p15:sldGuideLst>
+    </p:ext>
+  </p:extLst>
 </p:presentation>
+</file>
+
+<file path=ppt/notesMasters/notesMaster1.xml><?xml version="1.0" encoding="utf-8"?>
+<p:notesMaster xmlns:a="http://schemas.openxmlformats.org/drawingml/2006/main" xmlns:r="http://schemas.openxmlformats.org/officeDocument/2006/relationships" xmlns:p="http://schemas.openxmlformats.org/presentationml/2006/main">
+  <p:cSld>
+    <p:bg>
+      <p:bgRef idx="1001">
+        <a:schemeClr val="bg1"/>
+      </p:bgRef>
+    </p:bg>
+    <p:spTree>
+      <p:nvGrpSpPr>
+        <p:cNvPr id="1" name=""/>
+        <p:cNvGrpSpPr/>
+        <p:nvPr/>
+      </p:nvGrpSpPr>
+      <p:grpSpPr>
+        <a:xfrm>
+          <a:off x="0" y="0"/>
+          <a:ext cx="0" cy="0"/>
+          <a:chOff x="0" y="0"/>
+          <a:chExt cx="0" cy="0"/>
+        </a:xfrm>
+      </p:grpSpPr>
+      <p:sp>
+        <p:nvSpPr>
+          <p:cNvPr id="2" name="Header Placeholder 1"/>
+          <p:cNvSpPr>
+            <a:spLocks noGrp="1"/>
+          </p:cNvSpPr>
+          <p:nvPr>
+            <p:ph type="hdr" sz="quarter"/>
+          </p:nvPr>
+        </p:nvSpPr>
+        <p:spPr>
+          <a:xfrm>
+            <a:off x="0" y="0"/>
+            <a:ext cx="2971800" cy="458788"/>
+          </a:xfrm>
+          <a:prstGeom prst="rect">
+            <a:avLst/>
+          </a:prstGeom>
+        </p:spPr>
+        <p:txBody>
+          <a:bodyPr vert="horz" lIns="91440" tIns="45720" rIns="91440" bIns="45720" rtlCol="0"/>
+          <a:lstStyle>
+            <a:lvl1pPr algn="l">
+              <a:defRPr sz="1200"/>
+            </a:lvl1pPr>
+          </a:lstStyle>
+          <a:p>
+            <a:endParaRPr lang="en-US"/>
+          </a:p>
+        </p:txBody>
+      </p:sp>
+      <p:sp>
+        <p:nvSpPr>
+          <p:cNvPr id="3" name="Date Placeholder 2"/>
+          <p:cNvSpPr>
+            <a:spLocks noGrp="1"/>
+          </p:cNvSpPr>
+          <p:nvPr>
+            <p:ph type="dt" idx="1"/>
+          </p:nvPr>
+        </p:nvSpPr>
+        <p:spPr>
+          <a:xfrm>
+            <a:off x="3884613" y="0"/>
+            <a:ext cx="2971800" cy="458788"/>
+          </a:xfrm>
+          <a:prstGeom prst="rect">
+            <a:avLst/>
+          </a:prstGeom>
+        </p:spPr>
+        <p:txBody>
+          <a:bodyPr vert="horz" lIns="91440" tIns="45720" rIns="91440" bIns="45720" rtlCol="0"/>
+          <a:lstStyle>
+            <a:lvl1pPr algn="r">
+              <a:defRPr sz="1200"/>
+            </a:lvl1pPr>
+          </a:lstStyle>
+          <a:p>
+            <a:fld id="{A9740D39-A677-3649-BC73-6046EC616DE2}" type="datetimeFigureOut">
+              <a:rPr lang="en-US" smtClean="0"/>
+              <a:t>4/21/26</a:t>
+            </a:fld>
+            <a:endParaRPr lang="en-US"/>
+          </a:p>
+        </p:txBody>
+      </p:sp>
+      <p:sp>
+        <p:nvSpPr>
+          <p:cNvPr id="4" name="Slide Image Placeholder 3"/>
+          <p:cNvSpPr>
+            <a:spLocks noGrp="1" noRot="1" noChangeAspect="1"/>
+          </p:cNvSpPr>
+          <p:nvPr>
+            <p:ph type="sldImg" idx="2"/>
+          </p:nvPr>
+        </p:nvSpPr>
+        <p:spPr>
+          <a:xfrm>
+            <a:off x="1371600" y="1143000"/>
+            <a:ext cx="4114800" cy="3086100"/>
+          </a:xfrm>
+          <a:prstGeom prst="rect">
+            <a:avLst/>
+          </a:prstGeom>
+          <a:noFill/>
+          <a:ln w="12700">
+            <a:solidFill>
+              <a:prstClr val="black"/>
+            </a:solidFill>
+          </a:ln>
+        </p:spPr>
+        <p:txBody>
+          <a:bodyPr vert="horz" lIns="91440" tIns="45720" rIns="91440" bIns="45720" rtlCol="0" anchor="ctr"/>
+          <a:lstStyle/>
+          <a:p>
+            <a:endParaRPr lang="en-US"/>
+          </a:p>
+        </p:txBody>
+      </p:sp>
+      <p:sp>
+        <p:nvSpPr>
+          <p:cNvPr id="5" name="Notes Placeholder 4"/>
+          <p:cNvSpPr>
+            <a:spLocks noGrp="1"/>
+          </p:cNvSpPr>
+          <p:nvPr>
+            <p:ph type="body" sz="quarter" idx="3"/>
+          </p:nvPr>
+        </p:nvSpPr>
+        <p:spPr>
+          <a:xfrm>
+            <a:off x="685800" y="4400550"/>
+            <a:ext cx="5486400" cy="3600450"/>
+          </a:xfrm>
+          <a:prstGeom prst="rect">
+            <a:avLst/>
+          </a:prstGeom>
+        </p:spPr>
+        <p:txBody>
+          <a:bodyPr vert="horz" lIns="91440" tIns="45720" rIns="91440" bIns="45720" rtlCol="0"/>
+          <a:lstStyle/>
+          <a:p>
+            <a:pPr lvl="0"/>
+            <a:r>
+              <a:rPr lang="en-US"/>
+              <a:t>Click to edit Master text styles</a:t>
+            </a:r>
+          </a:p>
+          <a:p>
+            <a:pPr lvl="1"/>
+            <a:r>
+              <a:rPr lang="en-US"/>
+              <a:t>Second level</a:t>
+            </a:r>
+          </a:p>
+          <a:p>
+            <a:pPr lvl="2"/>
+            <a:r>
+              <a:rPr lang="en-US"/>
+              <a:t>Third level</a:t>
+            </a:r>
+          </a:p>
+          <a:p>
+            <a:pPr lvl="3"/>
+            <a:r>
+              <a:rPr lang="en-US"/>
+              <a:t>Fourth level</a:t>
+            </a:r>
+          </a:p>
+          <a:p>
+            <a:pPr lvl="4"/>
+            <a:r>
+              <a:rPr lang="en-US"/>
+              <a:t>Fifth level</a:t>
+            </a:r>
+          </a:p>
+        </p:txBody>
+      </p:sp>
+      <p:sp>
+        <p:nvSpPr>
+          <p:cNvPr id="6" name="Footer Placeholder 5"/>
+          <p:cNvSpPr>
+            <a:spLocks noGrp="1"/>
+          </p:cNvSpPr>
+          <p:nvPr>
+            <p:ph type="ftr" sz="quarter" idx="4"/>
+          </p:nvPr>
+        </p:nvSpPr>
+        <p:spPr>
+          <a:xfrm>
+            <a:off x="0" y="8685213"/>
+            <a:ext cx="2971800" cy="458787"/>
+          </a:xfrm>
+          <a:prstGeom prst="rect">
+            <a:avLst/>
+          </a:prstGeom>
+        </p:spPr>
+        <p:txBody>
+          <a:bodyPr vert="horz" lIns="91440" tIns="45720" rIns="91440" bIns="45720" rtlCol="0" anchor="b"/>
+          <a:lstStyle>
+            <a:lvl1pPr algn="l">
+              <a:defRPr sz="1200"/>
+            </a:lvl1pPr>
+          </a:lstStyle>
+          <a:p>
+            <a:endParaRPr lang="en-US"/>
+          </a:p>
+        </p:txBody>
+      </p:sp>
+      <p:sp>
+        <p:nvSpPr>
+          <p:cNvPr id="7" name="Slide Number Placeholder 6"/>
+          <p:cNvSpPr>
+            <a:spLocks noGrp="1"/>
+          </p:cNvSpPr>
+          <p:nvPr>
+            <p:ph type="sldNum" sz="quarter" idx="5"/>
+          </p:nvPr>
+        </p:nvSpPr>
+        <p:spPr>
+          <a:xfrm>
+            <a:off x="3884613" y="8685213"/>
+            <a:ext cx="2971800" cy="458787"/>
+          </a:xfrm>
+          <a:prstGeom prst="rect">
+            <a:avLst/>
+          </a:prstGeom>
+        </p:spPr>
+        <p:txBody>
+          <a:bodyPr vert="horz" lIns="91440" tIns="45720" rIns="91440" bIns="45720" rtlCol="0" anchor="b"/>
+          <a:lstStyle>
+            <a:lvl1pPr algn="r">
+              <a:defRPr sz="1200"/>
+            </a:lvl1pPr>
+          </a:lstStyle>
+          <a:p>
+            <a:fld id="{1041FC06-D6B9-DF46-AF07-126B45F4F05D}" type="slidenum">
+              <a:rPr lang="en-US" smtClean="0"/>
+              <a:t>‹#›</a:t>
+            </a:fld>
+            <a:endParaRPr lang="en-US"/>
+          </a:p>
+        </p:txBody>
+      </p:sp>
+    </p:spTree>
+    <p:extLst>
+      <p:ext uri="{BB962C8B-B14F-4D97-AF65-F5344CB8AC3E}">
+        <p14:creationId xmlns:p14="http://schemas.microsoft.com/office/powerpoint/2010/main" val="1706195749"/>
+      </p:ext>
+    </p:extLst>
+  </p:cSld>
+  <p:clrMap bg1="lt1" tx1="dk1" bg2="lt2" tx2="dk2" accent1="accent1" accent2="accent2" accent3="accent3" accent4="accent4" accent5="accent5" accent6="accent6" hlink="hlink" folHlink="folHlink"/>
+  <p:notesStyle>
+    <a:lvl1pPr marL="0" algn="l" defTabSz="914400" rtl="0" eaLnBrk="1" latinLnBrk="0" hangingPunct="1">
+      <a:defRPr sz="1200" kern="1200">
+        <a:solidFill>
+          <a:schemeClr val="tx1"/>
+        </a:solidFill>
+        <a:latin typeface="+mn-lt"/>
+        <a:ea typeface="+mn-ea"/>
+        <a:cs typeface="+mn-cs"/>
+      </a:defRPr>
+    </a:lvl1pPr>
+    <a:lvl2pPr marL="457200" algn="l" defTabSz="914400" rtl="0" eaLnBrk="1" latinLnBrk="0" hangingPunct="1">
+      <a:defRPr sz="1200" kern="1200">
+        <a:solidFill>
+          <a:schemeClr val="tx1"/>
+        </a:solidFill>
+        <a:latin typeface="+mn-lt"/>
+        <a:ea typeface="+mn-ea"/>
+        <a:cs typeface="+mn-cs"/>
+      </a:defRPr>
+    </a:lvl2pPr>
+    <a:lvl3pPr marL="914400" algn="l" defTabSz="914400" rtl="0" eaLnBrk="1" latinLnBrk="0" hangingPunct="1">
+      <a:defRPr sz="1200" kern="1200">
+        <a:solidFill>
+          <a:schemeClr val="tx1"/>
+        </a:solidFill>
+        <a:latin typeface="+mn-lt"/>
+        <a:ea typeface="+mn-ea"/>
+        <a:cs typeface="+mn-cs"/>
+      </a:defRPr>
+    </a:lvl3pPr>
+    <a:lvl4pPr marL="1371600" algn="l" defTabSz="914400" rtl="0" eaLnBrk="1" latinLnBrk="0" hangingPunct="1">
+      <a:defRPr sz="1200" kern="1200">
+        <a:solidFill>
+          <a:schemeClr val="tx1"/>
+        </a:solidFill>
+        <a:latin typeface="+mn-lt"/>
+        <a:ea typeface="+mn-ea"/>
+        <a:cs typeface="+mn-cs"/>
+      </a:defRPr>
+    </a:lvl4pPr>
+    <a:lvl5pPr marL="1828800" algn="l" defTabSz="914400" rtl="0" eaLnBrk="1" latinLnBrk="0" hangingPunct="1">
+      <a:defRPr sz="1200" kern="1200">
+        <a:solidFill>
+          <a:schemeClr val="tx1"/>
+        </a:solidFill>
+        <a:latin typeface="+mn-lt"/>
+        <a:ea typeface="+mn-ea"/>
+        <a:cs typeface="+mn-cs"/>
+      </a:defRPr>
+    </a:lvl5pPr>
+    <a:lvl6pPr marL="2286000" algn="l" defTabSz="914400" rtl="0" eaLnBrk="1" latinLnBrk="0" hangingPunct="1">
+      <a:defRPr sz="1200" kern="1200">
+        <a:solidFill>
+          <a:schemeClr val="tx1"/>
+        </a:solidFill>
+        <a:latin typeface="+mn-lt"/>
+        <a:ea typeface="+mn-ea"/>
+        <a:cs typeface="+mn-cs"/>
+      </a:defRPr>
+    </a:lvl6pPr>
+    <a:lvl7pPr marL="2743200" algn="l" defTabSz="914400" rtl="0" eaLnBrk="1" latinLnBrk="0" hangingPunct="1">
+      <a:defRPr sz="1200" kern="1200">
+        <a:solidFill>
+          <a:schemeClr val="tx1"/>
+        </a:solidFill>
+        <a:latin typeface="+mn-lt"/>
+        <a:ea typeface="+mn-ea"/>
+        <a:cs typeface="+mn-cs"/>
+      </a:defRPr>
+    </a:lvl7pPr>
+    <a:lvl8pPr marL="3200400" algn="l" defTabSz="914400" rtl="0" eaLnBrk="1" latinLnBrk="0" hangingPunct="1">
+      <a:defRPr sz="1200" kern="1200">
+        <a:solidFill>
+          <a:schemeClr val="tx1"/>
+        </a:solidFill>
+        <a:latin typeface="+mn-lt"/>
+        <a:ea typeface="+mn-ea"/>
+        <a:cs typeface="+mn-cs"/>
+      </a:defRPr>
+    </a:lvl8pPr>
+    <a:lvl9pPr marL="3657600" algn="l" defTabSz="914400" rtl="0" eaLnBrk="1" latinLnBrk="0" hangingPunct="1">
+      <a:defRPr sz="1200" kern="1200">
+        <a:solidFill>
+          <a:schemeClr val="tx1"/>
+        </a:solidFill>
+        <a:latin typeface="+mn-lt"/>
+        <a:ea typeface="+mn-ea"/>
+        <a:cs typeface="+mn-cs"/>
+      </a:defRPr>
+    </a:lvl9pPr>
+  </p:notesStyle>
+</p:notesMaster>
+</file>
+
+<file path=ppt/notesSlides/notesSlide1.xml><?xml version="1.0" encoding="utf-8"?>
+<p:notes xmlns:a="http://schemas.openxmlformats.org/drawingml/2006/main" xmlns:r="http://schemas.openxmlformats.org/officeDocument/2006/relationships" xmlns:p="http://schemas.openxmlformats.org/presentationml/2006/main">
+  <p:cSld>
+    <p:spTree>
+      <p:nvGrpSpPr>
+        <p:cNvPr id="1" name=""/>
+        <p:cNvGrpSpPr/>
+        <p:nvPr/>
+      </p:nvGrpSpPr>
+      <p:grpSpPr>
+        <a:xfrm>
+          <a:off x="0" y="0"/>
+          <a:ext cx="0" cy="0"/>
+          <a:chOff x="0" y="0"/>
+          <a:chExt cx="0" cy="0"/>
+        </a:xfrm>
+      </p:grpSpPr>
+      <p:sp>
+        <p:nvSpPr>
+          <p:cNvPr id="2" name="Slide Image Placeholder 1"/>
+          <p:cNvSpPr>
+            <a:spLocks noGrp="1" noRot="1" noChangeAspect="1"/>
+          </p:cNvSpPr>
+          <p:nvPr>
+            <p:ph type="sldImg"/>
+          </p:nvPr>
+        </p:nvSpPr>
+        <p:spPr/>
+      </p:sp>
+      <p:sp>
+        <p:nvSpPr>
+          <p:cNvPr id="3" name="Notes Placeholder 2"/>
+          <p:cNvSpPr>
+            <a:spLocks noGrp="1"/>
+          </p:cNvSpPr>
+          <p:nvPr>
+            <p:ph type="body" idx="1"/>
+          </p:nvPr>
+        </p:nvSpPr>
+        <p:spPr/>
+        <p:txBody>
+          <a:bodyPr/>
+          <a:lstStyle/>
+          <a:p>
+            <a:r>
+              <a:rPr lang="en-US" dirty="0"/>
+              <a:t>HHI – diversification per stock</a:t>
+            </a:r>
+          </a:p>
+          <a:p>
+            <a:endParaRPr lang="en-US" dirty="0"/>
+          </a:p>
+          <a:p>
+            <a:r>
+              <a:rPr lang="en-US" dirty="0"/>
+              <a:t>Sector HHI – diversification per sector</a:t>
+            </a:r>
+          </a:p>
+          <a:p>
+            <a:endParaRPr lang="en-US" dirty="0"/>
+          </a:p>
+          <a:p>
+            <a:r>
+              <a:rPr lang="en-US" dirty="0"/>
+              <a:t>Portfolio Beta - measures </a:t>
+            </a:r>
+            <a:r>
+              <a:rPr lang="en-US" sz="1200" b="0" i="0" kern="1200" dirty="0">
+                <a:solidFill>
+                  <a:schemeClr val="tx1"/>
+                </a:solidFill>
+                <a:effectLst/>
+                <a:latin typeface="+mn-lt"/>
+                <a:ea typeface="+mn-ea"/>
+                <a:cs typeface="+mn-cs"/>
+              </a:rPr>
+              <a:t>total sensitivity to market volatility, a B &gt; 1 means the portfolio is more volatile than the market and is a more aggressive portfolio, and a B &lt; 1 means the portfolio is less volatile than the market and is more defensive</a:t>
+            </a:r>
+          </a:p>
+          <a:p>
+            <a:endParaRPr lang="en-US" sz="1200" b="0" i="0" kern="1200" dirty="0">
+              <a:solidFill>
+                <a:schemeClr val="tx1"/>
+              </a:solidFill>
+              <a:effectLst/>
+              <a:latin typeface="+mn-lt"/>
+              <a:ea typeface="+mn-ea"/>
+              <a:cs typeface="+mn-cs"/>
+            </a:endParaRPr>
+          </a:p>
+          <a:p>
+            <a:r>
+              <a:rPr lang="en-US" sz="1200" b="0" i="0" kern="1200" dirty="0">
+                <a:solidFill>
+                  <a:schemeClr val="tx1"/>
+                </a:solidFill>
+                <a:effectLst/>
+                <a:latin typeface="+mn-lt"/>
+                <a:ea typeface="+mn-ea"/>
+                <a:cs typeface="+mn-cs"/>
+              </a:rPr>
+              <a:t>Portfolio vol (%) - This specific calculation represents the </a:t>
+            </a:r>
+            <a:r>
+              <a:rPr lang="en-US" sz="1200" b="1" i="0" kern="1200" dirty="0">
+                <a:solidFill>
+                  <a:schemeClr val="tx1"/>
+                </a:solidFill>
+                <a:effectLst/>
+                <a:latin typeface="+mn-lt"/>
+                <a:ea typeface="+mn-ea"/>
+                <a:cs typeface="+mn-cs"/>
+              </a:rPr>
+              <a:t>weighted average risk</a:t>
+            </a:r>
+            <a:r>
+              <a:rPr lang="en-US" sz="1200" b="0" i="0" kern="1200" dirty="0">
+                <a:solidFill>
+                  <a:schemeClr val="tx1"/>
+                </a:solidFill>
+                <a:effectLst/>
+                <a:latin typeface="+mn-lt"/>
+                <a:ea typeface="+mn-ea"/>
+                <a:cs typeface="+mn-cs"/>
+              </a:rPr>
+              <a:t> of the individual assets, which is usually higher than the true portfolio volatility because it fails to account for the risk-reduction benefits of </a:t>
+            </a:r>
+            <a:r>
+              <a:rPr lang="en-US" sz="1200" b="1" i="0" kern="1200" dirty="0">
+                <a:solidFill>
+                  <a:schemeClr val="tx1"/>
+                </a:solidFill>
+                <a:effectLst/>
+                <a:latin typeface="+mn-lt"/>
+                <a:ea typeface="+mn-ea"/>
+                <a:cs typeface="+mn-cs"/>
+              </a:rPr>
+              <a:t>diversification</a:t>
+            </a:r>
+            <a:endParaRPr lang="en-US" sz="1200" b="0" i="0" kern="1200" dirty="0">
+              <a:solidFill>
+                <a:schemeClr val="tx1"/>
+              </a:solidFill>
+              <a:effectLst/>
+              <a:latin typeface="+mn-lt"/>
+              <a:ea typeface="+mn-ea"/>
+              <a:cs typeface="+mn-cs"/>
+            </a:endParaRPr>
+          </a:p>
+          <a:p>
+            <a:endParaRPr lang="en-US" sz="1200" b="0" i="0" kern="1200" dirty="0">
+              <a:solidFill>
+                <a:schemeClr val="tx1"/>
+              </a:solidFill>
+              <a:effectLst/>
+              <a:latin typeface="+mn-lt"/>
+              <a:ea typeface="+mn-ea"/>
+              <a:cs typeface="+mn-cs"/>
+            </a:endParaRPr>
+          </a:p>
+          <a:p>
+            <a:r>
+              <a:rPr lang="en-US" sz="1200" b="0" i="0" kern="1200" dirty="0">
+                <a:solidFill>
+                  <a:schemeClr val="tx1"/>
+                </a:solidFill>
+                <a:effectLst/>
+                <a:latin typeface="+mn-lt"/>
+                <a:ea typeface="+mn-ea"/>
+                <a:cs typeface="+mn-cs"/>
+              </a:rPr>
+              <a:t>Breadth – measures how many different stocks are invested in on average, basically how many stocks got 0 weight</a:t>
+            </a:r>
+          </a:p>
+          <a:p>
+            <a:endParaRPr lang="en-US" sz="1200" b="0" i="0" kern="1200" dirty="0">
+              <a:solidFill>
+                <a:schemeClr val="tx1"/>
+              </a:solidFill>
+              <a:effectLst/>
+              <a:latin typeface="+mn-lt"/>
+              <a:ea typeface="+mn-ea"/>
+              <a:cs typeface="+mn-cs"/>
+            </a:endParaRPr>
+          </a:p>
+          <a:p>
+            <a:endParaRPr lang="en-US" dirty="0"/>
+          </a:p>
+        </p:txBody>
+      </p:sp>
+      <p:sp>
+        <p:nvSpPr>
+          <p:cNvPr id="4" name="Slide Number Placeholder 3"/>
+          <p:cNvSpPr>
+            <a:spLocks noGrp="1"/>
+          </p:cNvSpPr>
+          <p:nvPr>
+            <p:ph type="sldNum" sz="quarter" idx="5"/>
+          </p:nvPr>
+        </p:nvSpPr>
+        <p:spPr/>
+        <p:txBody>
+          <a:bodyPr/>
+          <a:lstStyle/>
+          <a:p>
+            <a:fld id="{1041FC06-D6B9-DF46-AF07-126B45F4F05D}" type="slidenum">
+              <a:rPr lang="en-US" smtClean="0"/>
+              <a:t>5</a:t>
+            </a:fld>
+            <a:endParaRPr lang="en-US"/>
+          </a:p>
+        </p:txBody>
+      </p:sp>
+    </p:spTree>
+    <p:extLst>
+      <p:ext uri="{BB962C8B-B14F-4D97-AF65-F5344CB8AC3E}">
+        <p14:creationId xmlns:p14="http://schemas.microsoft.com/office/powerpoint/2010/main" val="3508591315"/>
+      </p:ext>
+    </p:extLst>
+  </p:cSld>
+  <p:clrMapOvr>
+    <a:masterClrMapping/>
+  </p:clrMapOvr>
+</p:notes>
 </file>
 
 <file path=ppt/slideLayouts/slideLayout1.xml><?xml version="1.0" encoding="utf-8"?>
@@ -154,10 +748,9 @@
           <a:lstStyle/>
           <a:p>
             <a:r>
-              <a:rPr lang="en-US" smtClean="0"/>
+              <a:rPr lang="en-US"/>
               <a:t>Click to edit Master title style</a:t>
             </a:r>
-            <a:endParaRPr lang="en-US"/>
           </a:p>
         </p:txBody>
       </p:sp>
@@ -273,10 +866,9 @@
           </a:lstStyle>
           <a:p>
             <a:r>
-              <a:rPr lang="en-US" smtClean="0"/>
+              <a:rPr lang="en-US"/>
               <a:t>Click to edit Master subtitle style</a:t>
             </a:r>
-            <a:endParaRPr lang="en-US"/>
           </a:p>
         </p:txBody>
       </p:sp>
@@ -297,7 +889,7 @@
           <a:p>
             <a:fld id="{5BCAD085-E8A6-8845-BD4E-CB4CCA059FC4}" type="datetimeFigureOut">
               <a:rPr lang="en-US" smtClean="0"/>
-              <a:t>1/27/13</a:t>
+              <a:t>4/21/26</a:t>
             </a:fld>
             <a:endParaRPr lang="en-US"/>
           </a:p>
@@ -391,10 +983,9 @@
           <a:lstStyle/>
           <a:p>
             <a:r>
-              <a:rPr lang="en-US" smtClean="0"/>
+              <a:rPr lang="en-US"/>
               <a:t>Click to edit Master title style</a:t>
             </a:r>
-            <a:endParaRPr lang="en-US"/>
           </a:p>
         </p:txBody>
       </p:sp>
@@ -415,38 +1006,37 @@
           <a:p>
             <a:pPr lvl="0"/>
             <a:r>
-              <a:rPr lang="en-US" smtClean="0"/>
+              <a:rPr lang="en-US"/>
               <a:t>Click to edit Master text styles</a:t>
             </a:r>
           </a:p>
           <a:p>
             <a:pPr lvl="1"/>
             <a:r>
-              <a:rPr lang="en-US" smtClean="0"/>
+              <a:rPr lang="en-US"/>
               <a:t>Second level</a:t>
             </a:r>
           </a:p>
           <a:p>
             <a:pPr lvl="2"/>
             <a:r>
-              <a:rPr lang="en-US" smtClean="0"/>
+              <a:rPr lang="en-US"/>
               <a:t>Third level</a:t>
             </a:r>
           </a:p>
           <a:p>
             <a:pPr lvl="3"/>
             <a:r>
-              <a:rPr lang="en-US" smtClean="0"/>
+              <a:rPr lang="en-US"/>
               <a:t>Fourth level</a:t>
             </a:r>
           </a:p>
           <a:p>
             <a:pPr lvl="4"/>
             <a:r>
-              <a:rPr lang="en-US" smtClean="0"/>
+              <a:rPr lang="en-US"/>
               <a:t>Fifth level</a:t>
             </a:r>
-            <a:endParaRPr lang="en-US"/>
           </a:p>
         </p:txBody>
       </p:sp>
@@ -467,7 +1057,7 @@
           <a:p>
             <a:fld id="{5BCAD085-E8A6-8845-BD4E-CB4CCA059FC4}" type="datetimeFigureOut">
               <a:rPr lang="en-US" smtClean="0"/>
-              <a:t>1/27/13</a:t>
+              <a:t>4/21/26</a:t>
             </a:fld>
             <a:endParaRPr lang="en-US"/>
           </a:p>
@@ -566,10 +1156,9 @@
           <a:lstStyle/>
           <a:p>
             <a:r>
-              <a:rPr lang="en-US" smtClean="0"/>
+              <a:rPr lang="en-US"/>
               <a:t>Click to edit Master title style</a:t>
             </a:r>
-            <a:endParaRPr lang="en-US"/>
           </a:p>
         </p:txBody>
       </p:sp>
@@ -595,38 +1184,37 @@
           <a:p>
             <a:pPr lvl="0"/>
             <a:r>
-              <a:rPr lang="en-US" smtClean="0"/>
+              <a:rPr lang="en-US"/>
               <a:t>Click to edit Master text styles</a:t>
             </a:r>
           </a:p>
           <a:p>
             <a:pPr lvl="1"/>
             <a:r>
-              <a:rPr lang="en-US" smtClean="0"/>
+              <a:rPr lang="en-US"/>
               <a:t>Second level</a:t>
             </a:r>
           </a:p>
           <a:p>
             <a:pPr lvl="2"/>
             <a:r>
-              <a:rPr lang="en-US" smtClean="0"/>
+              <a:rPr lang="en-US"/>
               <a:t>Third level</a:t>
             </a:r>
           </a:p>
           <a:p>
             <a:pPr lvl="3"/>
             <a:r>
-              <a:rPr lang="en-US" smtClean="0"/>
+              <a:rPr lang="en-US"/>
               <a:t>Fourth level</a:t>
             </a:r>
           </a:p>
           <a:p>
             <a:pPr lvl="4"/>
             <a:r>
-              <a:rPr lang="en-US" smtClean="0"/>
+              <a:rPr lang="en-US"/>
               <a:t>Fifth level</a:t>
             </a:r>
-            <a:endParaRPr lang="en-US"/>
           </a:p>
         </p:txBody>
       </p:sp>
@@ -647,7 +1235,7 @@
           <a:p>
             <a:fld id="{5BCAD085-E8A6-8845-BD4E-CB4CCA059FC4}" type="datetimeFigureOut">
               <a:rPr lang="en-US" smtClean="0"/>
-              <a:t>1/27/13</a:t>
+              <a:t>4/21/26</a:t>
             </a:fld>
             <a:endParaRPr lang="en-US"/>
           </a:p>
@@ -741,10 +1329,9 @@
           <a:lstStyle/>
           <a:p>
             <a:r>
-              <a:rPr lang="en-US" smtClean="0"/>
+              <a:rPr lang="en-US"/>
               <a:t>Click to edit Master title style</a:t>
             </a:r>
-            <a:endParaRPr lang="en-US"/>
           </a:p>
         </p:txBody>
       </p:sp>
@@ -765,38 +1352,37 @@
           <a:p>
             <a:pPr lvl="0"/>
             <a:r>
-              <a:rPr lang="en-US" smtClean="0"/>
+              <a:rPr lang="en-US"/>
               <a:t>Click to edit Master text styles</a:t>
             </a:r>
           </a:p>
           <a:p>
             <a:pPr lvl="1"/>
             <a:r>
-              <a:rPr lang="en-US" smtClean="0"/>
+              <a:rPr lang="en-US"/>
               <a:t>Second level</a:t>
             </a:r>
           </a:p>
           <a:p>
             <a:pPr lvl="2"/>
             <a:r>
-              <a:rPr lang="en-US" smtClean="0"/>
+              <a:rPr lang="en-US"/>
               <a:t>Third level</a:t>
             </a:r>
           </a:p>
           <a:p>
             <a:pPr lvl="3"/>
             <a:r>
-              <a:rPr lang="en-US" smtClean="0"/>
+              <a:rPr lang="en-US"/>
               <a:t>Fourth level</a:t>
             </a:r>
           </a:p>
           <a:p>
             <a:pPr lvl="4"/>
             <a:r>
-              <a:rPr lang="en-US" smtClean="0"/>
+              <a:rPr lang="en-US"/>
               <a:t>Fifth level</a:t>
             </a:r>
-            <a:endParaRPr lang="en-US"/>
           </a:p>
         </p:txBody>
       </p:sp>
@@ -817,7 +1403,7 @@
           <a:p>
             <a:fld id="{5BCAD085-E8A6-8845-BD4E-CB4CCA059FC4}" type="datetimeFigureOut">
               <a:rPr lang="en-US" smtClean="0"/>
-              <a:t>1/27/13</a:t>
+              <a:t>4/21/26</a:t>
             </a:fld>
             <a:endParaRPr lang="en-US"/>
           </a:p>
@@ -920,10 +1506,9 @@
           </a:lstStyle>
           <a:p>
             <a:r>
-              <a:rPr lang="en-US" smtClean="0"/>
+              <a:rPr lang="en-US"/>
               <a:t>Click to edit Master title style</a:t>
             </a:r>
-            <a:endParaRPr lang="en-US"/>
           </a:p>
         </p:txBody>
       </p:sp>
@@ -1040,7 +1625,7 @@
           <a:p>
             <a:pPr lvl="0"/>
             <a:r>
-              <a:rPr lang="en-US" smtClean="0"/>
+              <a:rPr lang="en-US"/>
               <a:t>Click to edit Master text styles</a:t>
             </a:r>
           </a:p>
@@ -1063,7 +1648,7 @@
           <a:p>
             <a:fld id="{5BCAD085-E8A6-8845-BD4E-CB4CCA059FC4}" type="datetimeFigureOut">
               <a:rPr lang="en-US" smtClean="0"/>
-              <a:t>1/27/13</a:t>
+              <a:t>4/21/26</a:t>
             </a:fld>
             <a:endParaRPr lang="en-US"/>
           </a:p>
@@ -1157,10 +1742,9 @@
           <a:lstStyle/>
           <a:p>
             <a:r>
-              <a:rPr lang="en-US" smtClean="0"/>
+              <a:rPr lang="en-US"/>
               <a:t>Click to edit Master title style</a:t>
             </a:r>
-            <a:endParaRPr lang="en-US"/>
           </a:p>
         </p:txBody>
       </p:sp>
@@ -1214,38 +1798,37 @@
           <a:p>
             <a:pPr lvl="0"/>
             <a:r>
-              <a:rPr lang="en-US" smtClean="0"/>
+              <a:rPr lang="en-US"/>
               <a:t>Click to edit Master text styles</a:t>
             </a:r>
           </a:p>
           <a:p>
             <a:pPr lvl="1"/>
             <a:r>
-              <a:rPr lang="en-US" smtClean="0"/>
+              <a:rPr lang="en-US"/>
               <a:t>Second level</a:t>
             </a:r>
           </a:p>
           <a:p>
             <a:pPr lvl="2"/>
             <a:r>
-              <a:rPr lang="en-US" smtClean="0"/>
+              <a:rPr lang="en-US"/>
               <a:t>Third level</a:t>
             </a:r>
           </a:p>
           <a:p>
             <a:pPr lvl="3"/>
             <a:r>
-              <a:rPr lang="en-US" smtClean="0"/>
+              <a:rPr lang="en-US"/>
               <a:t>Fourth level</a:t>
             </a:r>
           </a:p>
           <a:p>
             <a:pPr lvl="4"/>
             <a:r>
-              <a:rPr lang="en-US" smtClean="0"/>
+              <a:rPr lang="en-US"/>
               <a:t>Fifth level</a:t>
             </a:r>
-            <a:endParaRPr lang="en-US"/>
           </a:p>
         </p:txBody>
       </p:sp>
@@ -1299,38 +1882,37 @@
           <a:p>
             <a:pPr lvl="0"/>
             <a:r>
-              <a:rPr lang="en-US" smtClean="0"/>
+              <a:rPr lang="en-US"/>
               <a:t>Click to edit Master text styles</a:t>
             </a:r>
           </a:p>
           <a:p>
             <a:pPr lvl="1"/>
             <a:r>
-              <a:rPr lang="en-US" smtClean="0"/>
+              <a:rPr lang="en-US"/>
               <a:t>Second level</a:t>
             </a:r>
           </a:p>
           <a:p>
             <a:pPr lvl="2"/>
             <a:r>
-              <a:rPr lang="en-US" smtClean="0"/>
+              <a:rPr lang="en-US"/>
               <a:t>Third level</a:t>
             </a:r>
           </a:p>
           <a:p>
             <a:pPr lvl="3"/>
             <a:r>
-              <a:rPr lang="en-US" smtClean="0"/>
+              <a:rPr lang="en-US"/>
               <a:t>Fourth level</a:t>
             </a:r>
           </a:p>
           <a:p>
             <a:pPr lvl="4"/>
             <a:r>
-              <a:rPr lang="en-US" smtClean="0"/>
+              <a:rPr lang="en-US"/>
               <a:t>Fifth level</a:t>
             </a:r>
-            <a:endParaRPr lang="en-US"/>
           </a:p>
         </p:txBody>
       </p:sp>
@@ -1351,7 +1933,7 @@
           <a:p>
             <a:fld id="{5BCAD085-E8A6-8845-BD4E-CB4CCA059FC4}" type="datetimeFigureOut">
               <a:rPr lang="en-US" smtClean="0"/>
-              <a:t>1/27/13</a:t>
+              <a:t>4/21/26</a:t>
             </a:fld>
             <a:endParaRPr lang="en-US"/>
           </a:p>
@@ -1449,10 +2031,9 @@
           </a:lstStyle>
           <a:p>
             <a:r>
-              <a:rPr lang="en-US" smtClean="0"/>
+              <a:rPr lang="en-US"/>
               <a:t>Click to edit Master title style</a:t>
             </a:r>
-            <a:endParaRPr lang="en-US"/>
           </a:p>
         </p:txBody>
       </p:sp>
@@ -1515,7 +2096,7 @@
           <a:p>
             <a:pPr lvl="0"/>
             <a:r>
-              <a:rPr lang="en-US" smtClean="0"/>
+              <a:rPr lang="en-US"/>
               <a:t>Click to edit Master text styles</a:t>
             </a:r>
           </a:p>
@@ -1571,38 +2152,37 @@
           <a:p>
             <a:pPr lvl="0"/>
             <a:r>
-              <a:rPr lang="en-US" smtClean="0"/>
+              <a:rPr lang="en-US"/>
               <a:t>Click to edit Master text styles</a:t>
             </a:r>
           </a:p>
           <a:p>
             <a:pPr lvl="1"/>
             <a:r>
-              <a:rPr lang="en-US" smtClean="0"/>
+              <a:rPr lang="en-US"/>
               <a:t>Second level</a:t>
             </a:r>
           </a:p>
           <a:p>
             <a:pPr lvl="2"/>
             <a:r>
-              <a:rPr lang="en-US" smtClean="0"/>
+              <a:rPr lang="en-US"/>
               <a:t>Third level</a:t>
             </a:r>
           </a:p>
           <a:p>
             <a:pPr lvl="3"/>
             <a:r>
-              <a:rPr lang="en-US" smtClean="0"/>
+              <a:rPr lang="en-US"/>
               <a:t>Fourth level</a:t>
             </a:r>
           </a:p>
           <a:p>
             <a:pPr lvl="4"/>
             <a:r>
-              <a:rPr lang="en-US" smtClean="0"/>
+              <a:rPr lang="en-US"/>
               <a:t>Fifth level</a:t>
             </a:r>
-            <a:endParaRPr lang="en-US"/>
           </a:p>
         </p:txBody>
       </p:sp>
@@ -1665,7 +2245,7 @@
           <a:p>
             <a:pPr lvl="0"/>
             <a:r>
-              <a:rPr lang="en-US" smtClean="0"/>
+              <a:rPr lang="en-US"/>
               <a:t>Click to edit Master text styles</a:t>
             </a:r>
           </a:p>
@@ -1721,38 +2301,37 @@
           <a:p>
             <a:pPr lvl="0"/>
             <a:r>
-              <a:rPr lang="en-US" smtClean="0"/>
+              <a:rPr lang="en-US"/>
               <a:t>Click to edit Master text styles</a:t>
             </a:r>
           </a:p>
           <a:p>
             <a:pPr lvl="1"/>
             <a:r>
-              <a:rPr lang="en-US" smtClean="0"/>
+              <a:rPr lang="en-US"/>
               <a:t>Second level</a:t>
             </a:r>
           </a:p>
           <a:p>
             <a:pPr lvl="2"/>
             <a:r>
-              <a:rPr lang="en-US" smtClean="0"/>
+              <a:rPr lang="en-US"/>
               <a:t>Third level</a:t>
             </a:r>
           </a:p>
           <a:p>
             <a:pPr lvl="3"/>
             <a:r>
-              <a:rPr lang="en-US" smtClean="0"/>
+              <a:rPr lang="en-US"/>
               <a:t>Fourth level</a:t>
             </a:r>
           </a:p>
           <a:p>
             <a:pPr lvl="4"/>
             <a:r>
-              <a:rPr lang="en-US" smtClean="0"/>
+              <a:rPr lang="en-US"/>
               <a:t>Fifth level</a:t>
             </a:r>
-            <a:endParaRPr lang="en-US"/>
           </a:p>
         </p:txBody>
       </p:sp>
@@ -1773,7 +2352,7 @@
           <a:p>
             <a:fld id="{5BCAD085-E8A6-8845-BD4E-CB4CCA059FC4}" type="datetimeFigureOut">
               <a:rPr lang="en-US" smtClean="0"/>
-              <a:t>1/27/13</a:t>
+              <a:t>4/21/26</a:t>
             </a:fld>
             <a:endParaRPr lang="en-US"/>
           </a:p>
@@ -1867,10 +2446,9 @@
           <a:lstStyle/>
           <a:p>
             <a:r>
-              <a:rPr lang="en-US" smtClean="0"/>
+              <a:rPr lang="en-US"/>
               <a:t>Click to edit Master title style</a:t>
             </a:r>
-            <a:endParaRPr lang="en-US"/>
           </a:p>
         </p:txBody>
       </p:sp>
@@ -1891,7 +2469,7 @@
           <a:p>
             <a:fld id="{5BCAD085-E8A6-8845-BD4E-CB4CCA059FC4}" type="datetimeFigureOut">
               <a:rPr lang="en-US" smtClean="0"/>
-              <a:t>1/27/13</a:t>
+              <a:t>4/21/26</a:t>
             </a:fld>
             <a:endParaRPr lang="en-US"/>
           </a:p>
@@ -1986,7 +2564,7 @@
           <a:p>
             <a:fld id="{5BCAD085-E8A6-8845-BD4E-CB4CCA059FC4}" type="datetimeFigureOut">
               <a:rPr lang="en-US" smtClean="0"/>
-              <a:t>1/27/13</a:t>
+              <a:t>4/21/26</a:t>
             </a:fld>
             <a:endParaRPr lang="en-US"/>
           </a:p>
@@ -2089,10 +2667,9 @@
           </a:lstStyle>
           <a:p>
             <a:r>
-              <a:rPr lang="en-US" smtClean="0"/>
+              <a:rPr lang="en-US"/>
               <a:t>Click to edit Master title style</a:t>
             </a:r>
-            <a:endParaRPr lang="en-US"/>
           </a:p>
         </p:txBody>
       </p:sp>
@@ -2146,38 +2723,37 @@
           <a:p>
             <a:pPr lvl="0"/>
             <a:r>
-              <a:rPr lang="en-US" smtClean="0"/>
+              <a:rPr lang="en-US"/>
               <a:t>Click to edit Master text styles</a:t>
             </a:r>
           </a:p>
           <a:p>
             <a:pPr lvl="1"/>
             <a:r>
-              <a:rPr lang="en-US" smtClean="0"/>
+              <a:rPr lang="en-US"/>
               <a:t>Second level</a:t>
             </a:r>
           </a:p>
           <a:p>
             <a:pPr lvl="2"/>
             <a:r>
-              <a:rPr lang="en-US" smtClean="0"/>
+              <a:rPr lang="en-US"/>
               <a:t>Third level</a:t>
             </a:r>
           </a:p>
           <a:p>
             <a:pPr lvl="3"/>
             <a:r>
-              <a:rPr lang="en-US" smtClean="0"/>
+              <a:rPr lang="en-US"/>
               <a:t>Fourth level</a:t>
             </a:r>
           </a:p>
           <a:p>
             <a:pPr lvl="4"/>
             <a:r>
-              <a:rPr lang="en-US" smtClean="0"/>
+              <a:rPr lang="en-US"/>
               <a:t>Fifth level</a:t>
             </a:r>
-            <a:endParaRPr lang="en-US"/>
           </a:p>
         </p:txBody>
       </p:sp>
@@ -2240,7 +2816,7 @@
           <a:p>
             <a:pPr lvl="0"/>
             <a:r>
-              <a:rPr lang="en-US" smtClean="0"/>
+              <a:rPr lang="en-US"/>
               <a:t>Click to edit Master text styles</a:t>
             </a:r>
           </a:p>
@@ -2263,7 +2839,7 @@
           <a:p>
             <a:fld id="{5BCAD085-E8A6-8845-BD4E-CB4CCA059FC4}" type="datetimeFigureOut">
               <a:rPr lang="en-US" smtClean="0"/>
-              <a:t>1/27/13</a:t>
+              <a:t>4/21/26</a:t>
             </a:fld>
             <a:endParaRPr lang="en-US"/>
           </a:p>
@@ -2366,10 +2942,9 @@
           </a:lstStyle>
           <a:p>
             <a:r>
-              <a:rPr lang="en-US" smtClean="0"/>
+              <a:rPr lang="en-US"/>
               <a:t>Click to edit Master title style</a:t>
             </a:r>
-            <a:endParaRPr lang="en-US"/>
           </a:p>
         </p:txBody>
       </p:sp>
@@ -2493,7 +3068,7 @@
           <a:p>
             <a:pPr lvl="0"/>
             <a:r>
-              <a:rPr lang="en-US" smtClean="0"/>
+              <a:rPr lang="en-US"/>
               <a:t>Click to edit Master text styles</a:t>
             </a:r>
           </a:p>
@@ -2516,7 +3091,7 @@
           <a:p>
             <a:fld id="{5BCAD085-E8A6-8845-BD4E-CB4CCA059FC4}" type="datetimeFigureOut">
               <a:rPr lang="en-US" smtClean="0"/>
-              <a:t>1/27/13</a:t>
+              <a:t>4/21/26</a:t>
             </a:fld>
             <a:endParaRPr lang="en-US"/>
           </a:p>
@@ -2625,10 +3200,9 @@
           <a:lstStyle/>
           <a:p>
             <a:r>
-              <a:rPr lang="en-US" smtClean="0"/>
+              <a:rPr lang="en-US"/>
               <a:t>Click to edit Master title style</a:t>
             </a:r>
-            <a:endParaRPr lang="en-US"/>
           </a:p>
         </p:txBody>
       </p:sp>
@@ -2659,38 +3233,37 @@
           <a:p>
             <a:pPr lvl="0"/>
             <a:r>
-              <a:rPr lang="en-US" smtClean="0"/>
+              <a:rPr lang="en-US"/>
               <a:t>Click to edit Master text styles</a:t>
             </a:r>
           </a:p>
           <a:p>
             <a:pPr lvl="1"/>
             <a:r>
-              <a:rPr lang="en-US" smtClean="0"/>
+              <a:rPr lang="en-US"/>
               <a:t>Second level</a:t>
             </a:r>
           </a:p>
           <a:p>
             <a:pPr lvl="2"/>
             <a:r>
-              <a:rPr lang="en-US" smtClean="0"/>
+              <a:rPr lang="en-US"/>
               <a:t>Third level</a:t>
             </a:r>
           </a:p>
           <a:p>
             <a:pPr lvl="3"/>
             <a:r>
-              <a:rPr lang="en-US" smtClean="0"/>
+              <a:rPr lang="en-US"/>
               <a:t>Fourth level</a:t>
             </a:r>
           </a:p>
           <a:p>
             <a:pPr lvl="4"/>
             <a:r>
-              <a:rPr lang="en-US" smtClean="0"/>
+              <a:rPr lang="en-US"/>
               <a:t>Fifth level</a:t>
             </a:r>
-            <a:endParaRPr lang="en-US"/>
           </a:p>
         </p:txBody>
       </p:sp>
@@ -2729,7 +3302,7 @@
           <a:p>
             <a:fld id="{5BCAD085-E8A6-8845-BD4E-CB4CCA059FC4}" type="datetimeFigureOut">
               <a:rPr lang="en-US" smtClean="0"/>
-              <a:t>1/27/13</a:t>
+              <a:t>4/21/26</a:t>
             </a:fld>
             <a:endParaRPr lang="en-US"/>
           </a:p>
@@ -3088,7 +3661,7 @@
 </file>
 
 <file path=ppt/slides/slide1.xml><?xml version="1.0" encoding="utf-8"?>
-<p:sld xmlns:a="http://schemas.openxmlformats.org/drawingml/2006/main" xmlns:p="http://schemas.openxmlformats.org/presentationml/2006/main" xmlns:r="http://schemas.openxmlformats.org/officeDocument/2006/relationships">
+<p:sld xmlns:a="http://schemas.openxmlformats.org/drawingml/2006/main" xmlns:r="http://schemas.openxmlformats.org/officeDocument/2006/relationships" xmlns:p="http://schemas.openxmlformats.org/presentationml/2006/main">
   <p:cSld>
     <p:spTree>
       <p:nvGrpSpPr>
@@ -3096,7 +3669,14 @@
         <p:cNvGrpSpPr/>
         <p:nvPr/>
       </p:nvGrpSpPr>
-      <p:grpSpPr/>
+      <p:grpSpPr>
+        <a:xfrm>
+          <a:off x="0" y="0"/>
+          <a:ext cx="0" cy="0"/>
+          <a:chOff x="0" y="0"/>
+          <a:chExt cx="0" cy="0"/>
+        </a:xfrm>
+      </p:grpSpPr>
       <p:sp>
         <p:nvSpPr>
           <p:cNvPr id="2" name="TextBox 1"/>
@@ -3106,7 +3686,7 @@
         <p:spPr>
           <a:xfrm>
             <a:off x="457200" y="1463040"/>
-            <a:ext cx="8229600" cy="1645920"/>
+            <a:ext cx="8229600" cy="1077218"/>
           </a:xfrm>
           <a:prstGeom prst="rect">
             <a:avLst/>
@@ -3121,13 +3701,16 @@
           <a:p>
             <a:pPr algn="ctr"/>
             <a:r>
-              <a:rPr sz="3200" b="1">
+              <a:rPr lang="en-US" sz="3200" b="1" dirty="0"/>
+              <a:t>Do Information Inputs Causally Affect LLM-Generated Investment Portfolios</a:t>
+            </a:r>
+            <a:r>
+              <a:rPr sz="3200" b="1" dirty="0">
                 <a:solidFill>
                   <a:srgbClr val="1F3A5F"/>
                 </a:solidFill>
               </a:rPr>
-              <a:t>Does the Information You Give an LLM
-Change the Portfolio It Builds?</a:t>
+              <a:t>?</a:t>
             </a:r>
           </a:p>
         </p:txBody>
@@ -3278,7 +3861,7 @@
 </file>
 
 <file path=ppt/slides/slide10.xml><?xml version="1.0" encoding="utf-8"?>
-<p:sld xmlns:a="http://schemas.openxmlformats.org/drawingml/2006/main" xmlns:p="http://schemas.openxmlformats.org/presentationml/2006/main" xmlns:r="http://schemas.openxmlformats.org/officeDocument/2006/relationships">
+<p:sld xmlns:a="http://schemas.openxmlformats.org/drawingml/2006/main" xmlns:r="http://schemas.openxmlformats.org/officeDocument/2006/relationships" xmlns:p="http://schemas.openxmlformats.org/presentationml/2006/main">
   <p:cSld>
     <p:spTree>
       <p:nvGrpSpPr>
@@ -3286,7 +3869,14 @@
         <p:cNvGrpSpPr/>
         <p:nvPr/>
       </p:nvGrpSpPr>
-      <p:grpSpPr/>
+      <p:grpSpPr>
+        <a:xfrm>
+          <a:off x="0" y="0"/>
+          <a:ext cx="0" cy="0"/>
+          <a:chOff x="0" y="0"/>
+          <a:chExt cx="0" cy="0"/>
+        </a:xfrm>
+      </p:grpSpPr>
       <p:sp>
         <p:nvSpPr>
           <p:cNvPr id="2" name="TextBox 1"/>
@@ -3617,7 +4207,7 @@
 </file>
 
 <file path=ppt/slides/slide2.xml><?xml version="1.0" encoding="utf-8"?>
-<p:sld xmlns:a="http://schemas.openxmlformats.org/drawingml/2006/main" xmlns:p="http://schemas.openxmlformats.org/presentationml/2006/main" xmlns:r="http://schemas.openxmlformats.org/officeDocument/2006/relationships">
+<p:sld xmlns:a="http://schemas.openxmlformats.org/drawingml/2006/main" xmlns:r="http://schemas.openxmlformats.org/officeDocument/2006/relationships" xmlns:p="http://schemas.openxmlformats.org/presentationml/2006/main">
   <p:cSld>
     <p:spTree>
       <p:nvGrpSpPr>
@@ -3625,7 +4215,14 @@
         <p:cNvGrpSpPr/>
         <p:nvPr/>
       </p:nvGrpSpPr>
-      <p:grpSpPr/>
+      <p:grpSpPr>
+        <a:xfrm>
+          <a:off x="0" y="0"/>
+          <a:ext cx="0" cy="0"/>
+          <a:chOff x="0" y="0"/>
+          <a:chExt cx="0" cy="0"/>
+        </a:xfrm>
+      </p:grpSpPr>
       <p:sp>
         <p:nvSpPr>
           <p:cNvPr id="2" name="TextBox 1"/>
@@ -3845,7 +4442,7 @@
 </file>
 
 <file path=ppt/slides/slide3.xml><?xml version="1.0" encoding="utf-8"?>
-<p:sld xmlns:a="http://schemas.openxmlformats.org/drawingml/2006/main" xmlns:p="http://schemas.openxmlformats.org/presentationml/2006/main" xmlns:r="http://schemas.openxmlformats.org/officeDocument/2006/relationships">
+<p:sld xmlns:a="http://schemas.openxmlformats.org/drawingml/2006/main" xmlns:r="http://schemas.openxmlformats.org/officeDocument/2006/relationships" xmlns:p="http://schemas.openxmlformats.org/presentationml/2006/main">
   <p:cSld>
     <p:spTree>
       <p:nvGrpSpPr>
@@ -3853,7 +4450,14 @@
         <p:cNvGrpSpPr/>
         <p:nvPr/>
       </p:nvGrpSpPr>
-      <p:grpSpPr/>
+      <p:grpSpPr>
+        <a:xfrm>
+          <a:off x="0" y="0"/>
+          <a:ext cx="0" cy="0"/>
+          <a:chOff x="0" y="0"/>
+          <a:chExt cx="0" cy="0"/>
+        </a:xfrm>
+      </p:grpSpPr>
       <p:sp>
         <p:nvSpPr>
           <p:cNvPr id="2" name="TextBox 1"/>
@@ -4278,7 +4882,7 @@
 </file>
 
 <file path=ppt/slides/slide4.xml><?xml version="1.0" encoding="utf-8"?>
-<p:sld xmlns:a="http://schemas.openxmlformats.org/drawingml/2006/main" xmlns:p="http://schemas.openxmlformats.org/presentationml/2006/main" xmlns:r="http://schemas.openxmlformats.org/officeDocument/2006/relationships">
+<p:sld xmlns:a="http://schemas.openxmlformats.org/drawingml/2006/main" xmlns:r="http://schemas.openxmlformats.org/officeDocument/2006/relationships" xmlns:p="http://schemas.openxmlformats.org/presentationml/2006/main">
   <p:cSld>
     <p:spTree>
       <p:nvGrpSpPr>
@@ -4286,7 +4890,14 @@
         <p:cNvGrpSpPr/>
         <p:nvPr/>
       </p:nvGrpSpPr>
-      <p:grpSpPr/>
+      <p:grpSpPr>
+        <a:xfrm>
+          <a:off x="0" y="0"/>
+          <a:ext cx="0" cy="0"/>
+          <a:chOff x="0" y="0"/>
+          <a:chExt cx="0" cy="0"/>
+        </a:xfrm>
+      </p:grpSpPr>
       <p:sp>
         <p:nvSpPr>
           <p:cNvPr id="2" name="TextBox 1"/>
@@ -4594,7 +5205,7 @@
 </file>
 
 <file path=ppt/slides/slide5.xml><?xml version="1.0" encoding="utf-8"?>
-<p:sld xmlns:a="http://schemas.openxmlformats.org/drawingml/2006/main" xmlns:p="http://schemas.openxmlformats.org/presentationml/2006/main" xmlns:r="http://schemas.openxmlformats.org/officeDocument/2006/relationships">
+<p:sld xmlns:a="http://schemas.openxmlformats.org/drawingml/2006/main" xmlns:r="http://schemas.openxmlformats.org/officeDocument/2006/relationships" xmlns:p="http://schemas.openxmlformats.org/presentationml/2006/main">
   <p:cSld>
     <p:spTree>
       <p:nvGrpSpPr>
@@ -4602,7 +5213,14 @@
         <p:cNvGrpSpPr/>
         <p:nvPr/>
       </p:nvGrpSpPr>
-      <p:grpSpPr/>
+      <p:grpSpPr>
+        <a:xfrm>
+          <a:off x="0" y="0"/>
+          <a:ext cx="0" cy="0"/>
+          <a:chOff x="0" y="0"/>
+          <a:chExt cx="0" cy="0"/>
+        </a:xfrm>
+      </p:grpSpPr>
       <p:sp>
         <p:nvSpPr>
           <p:cNvPr id="2" name="TextBox 1"/>
@@ -4656,11 +5274,41 @@
                 <a:tableStyleId>{5C22544A-7EE6-4342-B048-85BDC9FD1C3A}</a:tableStyleId>
               </a:tblPr>
               <a:tblGrid>
-                <a:gridCol w="1609344"/>
-                <a:gridCol w="1609344"/>
-                <a:gridCol w="1609344"/>
-                <a:gridCol w="1609344"/>
-                <a:gridCol w="1609344"/>
+                <a:gridCol w="1609344">
+                  <a:extLst>
+                    <a:ext uri="{9D8B030D-6E8A-4147-A177-3AD203B41FA5}">
+                      <a16:colId xmlns:a16="http://schemas.microsoft.com/office/drawing/2014/main" val="20000"/>
+                    </a:ext>
+                  </a:extLst>
+                </a:gridCol>
+                <a:gridCol w="1609344">
+                  <a:extLst>
+                    <a:ext uri="{9D8B030D-6E8A-4147-A177-3AD203B41FA5}">
+                      <a16:colId xmlns:a16="http://schemas.microsoft.com/office/drawing/2014/main" val="20001"/>
+                    </a:ext>
+                  </a:extLst>
+                </a:gridCol>
+                <a:gridCol w="1609344">
+                  <a:extLst>
+                    <a:ext uri="{9D8B030D-6E8A-4147-A177-3AD203B41FA5}">
+                      <a16:colId xmlns:a16="http://schemas.microsoft.com/office/drawing/2014/main" val="20002"/>
+                    </a:ext>
+                  </a:extLst>
+                </a:gridCol>
+                <a:gridCol w="1609344">
+                  <a:extLst>
+                    <a:ext uri="{9D8B030D-6E8A-4147-A177-3AD203B41FA5}">
+                      <a16:colId xmlns:a16="http://schemas.microsoft.com/office/drawing/2014/main" val="20003"/>
+                    </a:ext>
+                  </a:extLst>
+                </a:gridCol>
+                <a:gridCol w="1609344">
+                  <a:extLst>
+                    <a:ext uri="{9D8B030D-6E8A-4147-A177-3AD203B41FA5}">
+                      <a16:colId xmlns:a16="http://schemas.microsoft.com/office/drawing/2014/main" val="20004"/>
+                    </a:ext>
+                  </a:extLst>
+                </a:gridCol>
               </a:tblGrid>
               <a:tr h="487680">
                 <a:tc>
@@ -4669,6 +5317,7 @@
                     <a:lstStyle/>
                     <a:p>
                       <a:pPr algn="ctr"/>
+                      <a:endParaRPr/>
                     </a:p>
                   </a:txBody>
                   <a:tcPr>
@@ -4684,7 +5333,7 @@
                     <a:p>
                       <a:pPr algn="ctr"/>
                       <a:r>
-                        <a:rPr b="1" sz="1400">
+                        <a:rPr sz="1400" b="1">
                           <a:solidFill>
                             <a:srgbClr val="FFFFFF"/>
                           </a:solidFill>
@@ -4706,7 +5355,7 @@
                     <a:p>
                       <a:pPr algn="ctr"/>
                       <a:r>
-                        <a:rPr b="1" sz="1400">
+                        <a:rPr sz="1400" b="1">
                           <a:solidFill>
                             <a:srgbClr val="FFFFFF"/>
                           </a:solidFill>
@@ -4728,7 +5377,7 @@
                     <a:p>
                       <a:pPr algn="ctr"/>
                       <a:r>
-                        <a:rPr b="1" sz="1400">
+                        <a:rPr sz="1400" b="1">
                           <a:solidFill>
                             <a:srgbClr val="FFFFFF"/>
                           </a:solidFill>
@@ -4750,7 +5399,7 @@
                     <a:p>
                       <a:pPr algn="ctr"/>
                       <a:r>
-                        <a:rPr b="1" sz="1400">
+                        <a:rPr sz="1400" b="1">
                           <a:solidFill>
                             <a:srgbClr val="FFFFFF"/>
                           </a:solidFill>
@@ -4765,6 +5414,11 @@
                     </a:solidFill>
                   </a:tcPr>
                 </a:tc>
+                <a:extLst>
+                  <a:ext uri="{0D108BD9-81ED-4DB2-BD59-A6C34878D82A}">
+                    <a16:rowId xmlns:a16="http://schemas.microsoft.com/office/drawing/2014/main" val="10000"/>
+                  </a:ext>
+                </a:extLst>
               </a:tr>
               <a:tr h="487680">
                 <a:tc>
@@ -4837,6 +5491,11 @@
                   </a:txBody>
                   <a:tcPr/>
                 </a:tc>
+                <a:extLst>
+                  <a:ext uri="{0D108BD9-81ED-4DB2-BD59-A6C34878D82A}">
+                    <a16:rowId xmlns:a16="http://schemas.microsoft.com/office/drawing/2014/main" val="10001"/>
+                  </a:ext>
+                </a:extLst>
               </a:tr>
               <a:tr h="487680">
                 <a:tc>
@@ -4909,6 +5568,11 @@
                   </a:txBody>
                   <a:tcPr/>
                 </a:tc>
+                <a:extLst>
+                  <a:ext uri="{0D108BD9-81ED-4DB2-BD59-A6C34878D82A}">
+                    <a16:rowId xmlns:a16="http://schemas.microsoft.com/office/drawing/2014/main" val="10002"/>
+                  </a:ext>
+                </a:extLst>
               </a:tr>
               <a:tr h="487680">
                 <a:tc>
@@ -4981,6 +5645,11 @@
                   </a:txBody>
                   <a:tcPr/>
                 </a:tc>
+                <a:extLst>
+                  <a:ext uri="{0D108BD9-81ED-4DB2-BD59-A6C34878D82A}">
+                    <a16:rowId xmlns:a16="http://schemas.microsoft.com/office/drawing/2014/main" val="10003"/>
+                  </a:ext>
+                </a:extLst>
               </a:tr>
               <a:tr h="487680">
                 <a:tc>
@@ -4990,7 +5659,7 @@
                     <a:p>
                       <a:pPr algn="l"/>
                       <a:r>
-                        <a:rPr sz="1300" b="1"/>
+                        <a:rPr sz="1300" b="1" dirty="0"/>
                         <a:t>Portfolio vol (%)</a:t>
                       </a:r>
                     </a:p>
@@ -5053,6 +5722,11 @@
                   </a:txBody>
                   <a:tcPr/>
                 </a:tc>
+                <a:extLst>
+                  <a:ext uri="{0D108BD9-81ED-4DB2-BD59-A6C34878D82A}">
+                    <a16:rowId xmlns:a16="http://schemas.microsoft.com/office/drawing/2014/main" val="10004"/>
+                  </a:ext>
+                </a:extLst>
               </a:tr>
               <a:tr h="487680">
                 <a:tc>
@@ -5118,13 +5792,18 @@
                     <a:p>
                       <a:pPr algn="ctr"/>
                       <a:r>
-                        <a:rPr sz="1300"/>
+                        <a:rPr sz="1300" dirty="0"/>
                         <a:t>20.0</a:t>
                       </a:r>
                     </a:p>
                   </a:txBody>
                   <a:tcPr/>
                 </a:tc>
+                <a:extLst>
+                  <a:ext uri="{0D108BD9-81ED-4DB2-BD59-A6C34878D82A}">
+                    <a16:rowId xmlns:a16="http://schemas.microsoft.com/office/drawing/2014/main" val="10005"/>
+                  </a:ext>
+                </a:extLst>
               </a:tr>
             </a:tbl>
           </a:graphicData>
@@ -5241,7 +5920,7 @@
 </file>
 
 <file path=ppt/slides/slide6.xml><?xml version="1.0" encoding="utf-8"?>
-<p:sld xmlns:a="http://schemas.openxmlformats.org/drawingml/2006/main" xmlns:p="http://schemas.openxmlformats.org/presentationml/2006/main" xmlns:r="http://schemas.openxmlformats.org/officeDocument/2006/relationships">
+<p:sld xmlns:a="http://schemas.openxmlformats.org/drawingml/2006/main" xmlns:r="http://schemas.openxmlformats.org/officeDocument/2006/relationships" xmlns:p="http://schemas.openxmlformats.org/presentationml/2006/main">
   <p:cSld>
     <p:spTree>
       <p:nvGrpSpPr>
@@ -5249,7 +5928,14 @@
         <p:cNvGrpSpPr/>
         <p:nvPr/>
       </p:nvGrpSpPr>
-      <p:grpSpPr/>
+      <p:grpSpPr>
+        <a:xfrm>
+          <a:off x="0" y="0"/>
+          <a:ext cx="0" cy="0"/>
+          <a:chOff x="0" y="0"/>
+          <a:chExt cx="0" cy="0"/>
+        </a:xfrm>
+      </p:grpSpPr>
       <p:sp>
         <p:nvSpPr>
           <p:cNvPr id="2" name="TextBox 1"/>
@@ -5413,7 +6099,7 @@
 </file>
 
 <file path=ppt/slides/slide7.xml><?xml version="1.0" encoding="utf-8"?>
-<p:sld xmlns:a="http://schemas.openxmlformats.org/drawingml/2006/main" xmlns:p="http://schemas.openxmlformats.org/presentationml/2006/main" xmlns:r="http://schemas.openxmlformats.org/officeDocument/2006/relationships">
+<p:sld xmlns:a="http://schemas.openxmlformats.org/drawingml/2006/main" xmlns:r="http://schemas.openxmlformats.org/officeDocument/2006/relationships" xmlns:p="http://schemas.openxmlformats.org/presentationml/2006/main">
   <p:cSld>
     <p:spTree>
       <p:nvGrpSpPr>
@@ -5421,7 +6107,14 @@
         <p:cNvGrpSpPr/>
         <p:nvPr/>
       </p:nvGrpSpPr>
-      <p:grpSpPr/>
+      <p:grpSpPr>
+        <a:xfrm>
+          <a:off x="0" y="0"/>
+          <a:ext cx="0" cy="0"/>
+          <a:chOff x="0" y="0"/>
+          <a:chExt cx="0" cy="0"/>
+        </a:xfrm>
+      </p:grpSpPr>
       <p:sp>
         <p:nvSpPr>
           <p:cNvPr id="2" name="TextBox 1"/>
@@ -5576,7 +6269,7 @@
 </file>
 
 <file path=ppt/slides/slide8.xml><?xml version="1.0" encoding="utf-8"?>
-<p:sld xmlns:a="http://schemas.openxmlformats.org/drawingml/2006/main" xmlns:p="http://schemas.openxmlformats.org/presentationml/2006/main" xmlns:r="http://schemas.openxmlformats.org/officeDocument/2006/relationships">
+<p:sld xmlns:a="http://schemas.openxmlformats.org/drawingml/2006/main" xmlns:r="http://schemas.openxmlformats.org/officeDocument/2006/relationships" xmlns:p="http://schemas.openxmlformats.org/presentationml/2006/main">
   <p:cSld>
     <p:spTree>
       <p:nvGrpSpPr>
@@ -5584,7 +6277,14 @@
         <p:cNvGrpSpPr/>
         <p:nvPr/>
       </p:nvGrpSpPr>
-      <p:grpSpPr/>
+      <p:grpSpPr>
+        <a:xfrm>
+          <a:off x="0" y="0"/>
+          <a:ext cx="0" cy="0"/>
+          <a:chOff x="0" y="0"/>
+          <a:chExt cx="0" cy="0"/>
+        </a:xfrm>
+      </p:grpSpPr>
       <p:sp>
         <p:nvSpPr>
           <p:cNvPr id="2" name="TextBox 1"/>
@@ -5724,7 +6424,7 @@
 </file>
 
 <file path=ppt/slides/slide9.xml><?xml version="1.0" encoding="utf-8"?>
-<p:sld xmlns:a="http://schemas.openxmlformats.org/drawingml/2006/main" xmlns:p="http://schemas.openxmlformats.org/presentationml/2006/main" xmlns:r="http://schemas.openxmlformats.org/officeDocument/2006/relationships">
+<p:sld xmlns:a="http://schemas.openxmlformats.org/drawingml/2006/main" xmlns:r="http://schemas.openxmlformats.org/officeDocument/2006/relationships" xmlns:p="http://schemas.openxmlformats.org/presentationml/2006/main">
   <p:cSld>
     <p:spTree>
       <p:nvGrpSpPr>
@@ -5732,7 +6432,14 @@
         <p:cNvGrpSpPr/>
         <p:nvPr/>
       </p:nvGrpSpPr>
-      <p:grpSpPr/>
+      <p:grpSpPr>
+        <a:xfrm>
+          <a:off x="0" y="0"/>
+          <a:ext cx="0" cy="0"/>
+          <a:chOff x="0" y="0"/>
+          <a:chExt cx="0" cy="0"/>
+        </a:xfrm>
+      </p:grpSpPr>
       <p:sp>
         <p:nvSpPr>
           <p:cNvPr id="2" name="TextBox 1"/>
@@ -6377,4 +7084,319 @@
   </a:objectDefaults>
   <a:extraClrSchemeLst/>
 </a:theme>
+</file>
+
+<file path=ppt/theme/theme2.xml><?xml version="1.0" encoding="utf-8"?>
+<a:theme xmlns:a="http://schemas.openxmlformats.org/drawingml/2006/main" name="Office Theme">
+  <a:themeElements>
+    <a:clrScheme name="Office">
+      <a:dk1>
+        <a:sysClr val="windowText" lastClr="000000"/>
+      </a:dk1>
+      <a:lt1>
+        <a:sysClr val="window" lastClr="FFFFFF"/>
+      </a:lt1>
+      <a:dk2>
+        <a:srgbClr val="0E2841"/>
+      </a:dk2>
+      <a:lt2>
+        <a:srgbClr val="E8E8E8"/>
+      </a:lt2>
+      <a:accent1>
+        <a:srgbClr val="156082"/>
+      </a:accent1>
+      <a:accent2>
+        <a:srgbClr val="E97132"/>
+      </a:accent2>
+      <a:accent3>
+        <a:srgbClr val="196B24"/>
+      </a:accent3>
+      <a:accent4>
+        <a:srgbClr val="0F9ED5"/>
+      </a:accent4>
+      <a:accent5>
+        <a:srgbClr val="A02B93"/>
+      </a:accent5>
+      <a:accent6>
+        <a:srgbClr val="4EA72E"/>
+      </a:accent6>
+      <a:hlink>
+        <a:srgbClr val="467886"/>
+      </a:hlink>
+      <a:folHlink>
+        <a:srgbClr val="96607D"/>
+      </a:folHlink>
+    </a:clrScheme>
+    <a:fontScheme name="Office">
+      <a:majorFont>
+        <a:latin typeface="Aptos Display" panose="02110004020202020204"/>
+        <a:ea typeface=""/>
+        <a:cs typeface=""/>
+        <a:font script="Jpan" typeface="游ゴシック Light"/>
+        <a:font script="Hang" typeface="맑은 고딕"/>
+        <a:font script="Hans" typeface="等线 Light"/>
+        <a:font script="Hant" typeface="新細明體"/>
+        <a:font script="Arab" typeface="Times New Roman"/>
+        <a:font script="Hebr" typeface="Times New Roman"/>
+        <a:font script="Thai" typeface="Angsana New"/>
+        <a:font script="Ethi" typeface="Nyala"/>
+        <a:font script="Beng" typeface="Vrinda"/>
+        <a:font script="Gujr" typeface="Shruti"/>
+        <a:font script="Khmr" typeface="MoolBoran"/>
+        <a:font script="Knda" typeface="Tunga"/>
+        <a:font script="Guru" typeface="Raavi"/>
+        <a:font script="Cans" typeface="Euphemia"/>
+        <a:font script="Cher" typeface="Plantagenet Cherokee"/>
+        <a:font script="Yiii" typeface="Microsoft Yi Baiti"/>
+        <a:font script="Tibt" typeface="Microsoft Himalaya"/>
+        <a:font script="Thaa" typeface="MV Boli"/>
+        <a:font script="Deva" typeface="Mangal"/>
+        <a:font script="Telu" typeface="Gautami"/>
+        <a:font script="Taml" typeface="Latha"/>
+        <a:font script="Syrc" typeface="Estrangelo Edessa"/>
+        <a:font script="Orya" typeface="Kalinga"/>
+        <a:font script="Mlym" typeface="Kartika"/>
+        <a:font script="Laoo" typeface="DokChampa"/>
+        <a:font script="Sinh" typeface="Iskoola Pota"/>
+        <a:font script="Mong" typeface="Mongolian Baiti"/>
+        <a:font script="Viet" typeface="Times New Roman"/>
+        <a:font script="Uigh" typeface="Microsoft Uighur"/>
+        <a:font script="Geor" typeface="Sylfaen"/>
+        <a:font script="Armn" typeface="Arial"/>
+        <a:font script="Bugi" typeface="Leelawadee UI"/>
+        <a:font script="Bopo" typeface="Microsoft JhengHei"/>
+        <a:font script="Java" typeface="Javanese Text"/>
+        <a:font script="Lisu" typeface="Segoe UI"/>
+        <a:font script="Mymr" typeface="Myanmar Text"/>
+        <a:font script="Nkoo" typeface="Ebrima"/>
+        <a:font script="Olck" typeface="Nirmala UI"/>
+        <a:font script="Osma" typeface="Ebrima"/>
+        <a:font script="Phag" typeface="Phagspa"/>
+        <a:font script="Syrn" typeface="Estrangelo Edessa"/>
+        <a:font script="Syrj" typeface="Estrangelo Edessa"/>
+        <a:font script="Syre" typeface="Estrangelo Edessa"/>
+        <a:font script="Sora" typeface="Nirmala UI"/>
+        <a:font script="Tale" typeface="Microsoft Tai Le"/>
+        <a:font script="Talu" typeface="Microsoft New Tai Lue"/>
+        <a:font script="Tfng" typeface="Ebrima"/>
+      </a:majorFont>
+      <a:minorFont>
+        <a:latin typeface="Aptos" panose="02110004020202020204"/>
+        <a:ea typeface=""/>
+        <a:cs typeface=""/>
+        <a:font script="Jpan" typeface="游ゴシック"/>
+        <a:font script="Hang" typeface="맑은 고딕"/>
+        <a:font script="Hans" typeface="等线"/>
+        <a:font script="Hant" typeface="新細明體"/>
+        <a:font script="Arab" typeface="Arial"/>
+        <a:font script="Hebr" typeface="Arial"/>
+        <a:font script="Thai" typeface="Cordia New"/>
+        <a:font script="Ethi" typeface="Nyala"/>
+        <a:font script="Beng" typeface="Vrinda"/>
+        <a:font script="Gujr" typeface="Shruti"/>
+        <a:font script="Khmr" typeface="DaunPenh"/>
+        <a:font script="Knda" typeface="Tunga"/>
+        <a:font script="Guru" typeface="Raavi"/>
+        <a:font script="Cans" typeface="Euphemia"/>
+        <a:font script="Cher" typeface="Plantagenet Cherokee"/>
+        <a:font script="Yiii" typeface="Microsoft Yi Baiti"/>
+        <a:font script="Tibt" typeface="Microsoft Himalaya"/>
+        <a:font script="Thaa" typeface="MV Boli"/>
+        <a:font script="Deva" typeface="Mangal"/>
+        <a:font script="Telu" typeface="Gautami"/>
+        <a:font script="Taml" typeface="Latha"/>
+        <a:font script="Syrc" typeface="Estrangelo Edessa"/>
+        <a:font script="Orya" typeface="Kalinga"/>
+        <a:font script="Mlym" typeface="Kartika"/>
+        <a:font script="Laoo" typeface="DokChampa"/>
+        <a:font script="Sinh" typeface="Iskoola Pota"/>
+        <a:font script="Mong" typeface="Mongolian Baiti"/>
+        <a:font script="Viet" typeface="Arial"/>
+        <a:font script="Uigh" typeface="Microsoft Uighur"/>
+        <a:font script="Geor" typeface="Sylfaen"/>
+        <a:font script="Armn" typeface="Arial"/>
+        <a:font script="Bugi" typeface="Leelawadee UI"/>
+        <a:font script="Bopo" typeface="Microsoft JhengHei"/>
+        <a:font script="Java" typeface="Javanese Text"/>
+        <a:font script="Lisu" typeface="Segoe UI"/>
+        <a:font script="Mymr" typeface="Myanmar Text"/>
+        <a:font script="Nkoo" typeface="Ebrima"/>
+        <a:font script="Olck" typeface="Nirmala UI"/>
+        <a:font script="Osma" typeface="Ebrima"/>
+        <a:font script="Phag" typeface="Phagspa"/>
+        <a:font script="Syrn" typeface="Estrangelo Edessa"/>
+        <a:font script="Syrj" typeface="Estrangelo Edessa"/>
+        <a:font script="Syre" typeface="Estrangelo Edessa"/>
+        <a:font script="Sora" typeface="Nirmala UI"/>
+        <a:font script="Tale" typeface="Microsoft Tai Le"/>
+        <a:font script="Talu" typeface="Microsoft New Tai Lue"/>
+        <a:font script="Tfng" typeface="Ebrima"/>
+      </a:minorFont>
+    </a:fontScheme>
+    <a:fmtScheme name="Office">
+      <a:fillStyleLst>
+        <a:solidFill>
+          <a:schemeClr val="phClr"/>
+        </a:solidFill>
+        <a:gradFill rotWithShape="1">
+          <a:gsLst>
+            <a:gs pos="0">
+              <a:schemeClr val="phClr">
+                <a:lumMod val="110000"/>
+                <a:satMod val="105000"/>
+                <a:tint val="67000"/>
+              </a:schemeClr>
+            </a:gs>
+            <a:gs pos="50000">
+              <a:schemeClr val="phClr">
+                <a:lumMod val="105000"/>
+                <a:satMod val="103000"/>
+                <a:tint val="73000"/>
+              </a:schemeClr>
+            </a:gs>
+            <a:gs pos="100000">
+              <a:schemeClr val="phClr">
+                <a:lumMod val="105000"/>
+                <a:satMod val="109000"/>
+                <a:tint val="81000"/>
+              </a:schemeClr>
+            </a:gs>
+          </a:gsLst>
+          <a:lin ang="5400000" scaled="0"/>
+        </a:gradFill>
+        <a:gradFill rotWithShape="1">
+          <a:gsLst>
+            <a:gs pos="0">
+              <a:schemeClr val="phClr">
+                <a:satMod val="103000"/>
+                <a:lumMod val="102000"/>
+                <a:tint val="94000"/>
+              </a:schemeClr>
+            </a:gs>
+            <a:gs pos="50000">
+              <a:schemeClr val="phClr">
+                <a:satMod val="110000"/>
+                <a:lumMod val="100000"/>
+                <a:shade val="100000"/>
+              </a:schemeClr>
+            </a:gs>
+            <a:gs pos="100000">
+              <a:schemeClr val="phClr">
+                <a:lumMod val="99000"/>
+                <a:satMod val="120000"/>
+                <a:shade val="78000"/>
+              </a:schemeClr>
+            </a:gs>
+          </a:gsLst>
+          <a:lin ang="5400000" scaled="0"/>
+        </a:gradFill>
+      </a:fillStyleLst>
+      <a:lnStyleLst>
+        <a:ln w="12700" cap="flat" cmpd="sng" algn="ctr">
+          <a:solidFill>
+            <a:schemeClr val="phClr"/>
+          </a:solidFill>
+          <a:prstDash val="solid"/>
+          <a:miter lim="800000"/>
+        </a:ln>
+        <a:ln w="19050" cap="flat" cmpd="sng" algn="ctr">
+          <a:solidFill>
+            <a:schemeClr val="phClr"/>
+          </a:solidFill>
+          <a:prstDash val="solid"/>
+          <a:miter lim="800000"/>
+        </a:ln>
+        <a:ln w="25400" cap="flat" cmpd="sng" algn="ctr">
+          <a:solidFill>
+            <a:schemeClr val="phClr"/>
+          </a:solidFill>
+          <a:prstDash val="solid"/>
+          <a:miter lim="800000"/>
+        </a:ln>
+      </a:lnStyleLst>
+      <a:effectStyleLst>
+        <a:effectStyle>
+          <a:effectLst/>
+        </a:effectStyle>
+        <a:effectStyle>
+          <a:effectLst/>
+        </a:effectStyle>
+        <a:effectStyle>
+          <a:effectLst>
+            <a:outerShdw blurRad="57150" dist="19050" dir="5400000" algn="ctr" rotWithShape="0">
+              <a:srgbClr val="000000">
+                <a:alpha val="63000"/>
+              </a:srgbClr>
+            </a:outerShdw>
+          </a:effectLst>
+        </a:effectStyle>
+      </a:effectStyleLst>
+      <a:bgFillStyleLst>
+        <a:solidFill>
+          <a:schemeClr val="phClr"/>
+        </a:solidFill>
+        <a:solidFill>
+          <a:schemeClr val="phClr">
+            <a:tint val="95000"/>
+            <a:satMod val="170000"/>
+          </a:schemeClr>
+        </a:solidFill>
+        <a:gradFill rotWithShape="1">
+          <a:gsLst>
+            <a:gs pos="0">
+              <a:schemeClr val="phClr">
+                <a:tint val="93000"/>
+                <a:satMod val="150000"/>
+                <a:shade val="98000"/>
+                <a:lumMod val="102000"/>
+              </a:schemeClr>
+            </a:gs>
+            <a:gs pos="50000">
+              <a:schemeClr val="phClr">
+                <a:tint val="98000"/>
+                <a:satMod val="130000"/>
+                <a:shade val="90000"/>
+                <a:lumMod val="103000"/>
+              </a:schemeClr>
+            </a:gs>
+            <a:gs pos="100000">
+              <a:schemeClr val="phClr">
+                <a:shade val="63000"/>
+                <a:satMod val="120000"/>
+              </a:schemeClr>
+            </a:gs>
+          </a:gsLst>
+          <a:lin ang="5400000" scaled="0"/>
+        </a:gradFill>
+      </a:bgFillStyleLst>
+    </a:fmtScheme>
+  </a:themeElements>
+  <a:objectDefaults>
+    <a:lnDef>
+      <a:spPr/>
+      <a:bodyPr/>
+      <a:lstStyle/>
+      <a:style>
+        <a:lnRef idx="2">
+          <a:schemeClr val="accent1"/>
+        </a:lnRef>
+        <a:fillRef idx="0">
+          <a:schemeClr val="accent1"/>
+        </a:fillRef>
+        <a:effectRef idx="1">
+          <a:schemeClr val="accent1"/>
+        </a:effectRef>
+        <a:fontRef idx="minor">
+          <a:schemeClr val="tx1"/>
+        </a:fontRef>
+      </a:style>
+    </a:lnDef>
+  </a:objectDefaults>
+  <a:extraClrSchemeLst/>
+  <a:extLst>
+    <a:ext uri="{05A4C25C-085E-4340-85A3-A5531E510DB2}">
+      <thm15:themeFamily xmlns:thm15="http://schemas.microsoft.com/office/thememl/2012/main" name="Office Theme" id="{2E142A2C-CD16-42D6-873A-C26D2A0506FA}" vid="{1BDDFF52-6CD6-40A5-AB3C-68EB2F1E4D0A}"/>
+    </a:ext>
+  </a:extLst>
+</a:theme>
 </file>
</xml_diff>